<commit_message>
Meeting deck: trim to 5 slides (what it is, products mapped, live look, two-role goal)
Co-Authored-By: Claude Fable 5 <noreply@anthropic.com>
Claude-Session: https://claude.ai/code/session_019MdxDfxB8wg2Ht2aZSuwqK
</commit_message>
<xml_diff>
--- a/standard-work/standalone/Meritage_3D_Model_Overview.pptx
+++ b/standard-work/standalone/Meritage_3D_Model_Overview.pptx
@@ -10,9 +10,6 @@
     <p:sldId id="258" r:id="rId10"/>
     <p:sldId id="259" r:id="rId11"/>
     <p:sldId id="260" r:id="rId12"/>
-    <p:sldId id="261" r:id="rId13"/>
-    <p:sldId id="262" r:id="rId14"/>
-    <p:sldId id="263" r:id="rId7"/>
   </p:sldIdLst>
   <p:sldSz cx="12192000" cy="6858000"/>
   <p:notesSz cx="6858000" cy="9144000"/>
@@ -4006,7 +4003,7 @@
           <a:lstStyle/>
           <a:p>
             <a:r>
-              <a:t>Why I built this</a:t>
+              <a:t>What it is</a:t>
             </a:r>
           </a:p>
         </p:txBody>
@@ -4028,26 +4025,25 @@
           <a:p>
             <a:pPr/>
             <a:r>
-              <a:t>We were tasked with creating standard work for the mezzanine lines.</a:t>
+              <a:t>A 3D model of the mezzanine floor, built from the CAD layout.</a:t>
             </a:r>
           </a:p>
           <a:p>
             <a:pPr/>
             <a:r>
-              <a:t>That gave us a lot of good data (station times, people, sequence), but it lived in spreadsheets and SWIs.</a:t>
+              <a:t>All three lines run live (Meritage, Sola, Canyon Crew) using the real times from our SWIs.</a:t>
             </a:r>
           </a:p>
           <a:p>
             <a:pPr/>
             <a:r>
-              <a:t>I built this simulation as a way to actually see all of that data on the floor, and use it to reach conclusions about optimization.</a:t>
+              <a:t>Shows cycle, pace, capacity, and the bottleneck for each line, and updates the moment you change anything.</a:t>
             </a:r>
           </a:p>
           <a:p>
             <a:pPr/>
             <a:r>
-              <a:rPr b="1"/>
-              <a:t>The goal today: show you what we have, and plan strategies for each line together off the numbers we collected.</a:t>
+              <a:t>Runs in any browser. No install.</a:t>
             </a:r>
           </a:p>
         </p:txBody>
@@ -4086,7 +4082,7 @@
           <a:lstStyle/>
           <a:p>
             <a:r>
-              <a:t>What it is</a:t>
+              <a:t>Products mapped so far</a:t>
             </a:r>
           </a:p>
         </p:txBody>
@@ -4108,37 +4104,26 @@
           <a:p>
             <a:pPr/>
             <a:r>
-              <a:t>A 3D model of the mezzanine floor, the real layout, from the CAD drawing.</a:t>
+              <a:t>Meritage:  3-Seater, 2-Seater, Chair, Swivel Chair</a:t>
             </a:r>
           </a:p>
           <a:p>
             <a:pPr/>
             <a:r>
-              <a:t>All three lines run at once, each on its own schedule:</a:t>
-            </a:r>
-          </a:p>
-          <a:p>
-            <a:pPr lvl="1"/>
-            <a:r>
-              <a:t>Meritage, Sola, and Canyon Crew: operators, parts carts, forklifts, and finished-goods flow.</a:t>
+              <a:t>Sola Lounge:  no arms, 1 arm, both arms, middle leg</a:t>
             </a:r>
           </a:p>
           <a:p>
             <a:pPr/>
             <a:r>
-              <a:t>Every station uses the real times from our SWIs.</a:t>
+              <a:t>Canyon Crew:  Canyon Chair</a:t>
             </a:r>
           </a:p>
           <a:p>
             <a:pPr/>
             <a:r>
-              <a:t>Live readouts per line: cycle (total labor), current pace, capacity per day, and the bottleneck.</a:t>
-            </a:r>
-          </a:p>
-          <a:p>
-            <a:pPr/>
-            <a:r>
-              <a:t>Runs in any browser. No install.</a:t>
+              <a:rPr b="1"/>
+              <a:t>Each product carries its own real steps or a measured time factor, so labor and pace change when you switch products.</a:t>
             </a:r>
           </a:p>
         </p:txBody>
@@ -4152,184 +4137,6 @@
 </file>
 
 <file path=ppt/slides/slide4.xml><?xml version="1.0" encoding="utf-8"?>
-<p:sld xmlns:a="http://schemas.openxmlformats.org/drawingml/2006/main" xmlns:p="http://schemas.openxmlformats.org/presentationml/2006/main" xmlns:r="http://schemas.openxmlformats.org/officeDocument/2006/relationships">
-  <p:cSld>
-    <p:spTree>
-      <p:nvGrpSpPr>
-        <p:cNvPr id="1" name=""/>
-        <p:cNvGrpSpPr/>
-        <p:nvPr/>
-      </p:nvGrpSpPr>
-      <p:grpSpPr/>
-      <p:sp>
-        <p:nvSpPr>
-          <p:cNvPr id="2" name="Title 1"/>
-          <p:cNvSpPr>
-            <a:spLocks noGrp="1"/>
-          </p:cNvSpPr>
-          <p:nvPr>
-            <p:ph type="title"/>
-          </p:nvPr>
-        </p:nvSpPr>
-        <p:spPr/>
-        <p:txBody>
-          <a:bodyPr/>
-          <a:lstStyle/>
-          <a:p>
-            <a:r>
-              <a:t>What we can do with it</a:t>
-            </a:r>
-          </a:p>
-        </p:txBody>
-      </p:sp>
-      <p:sp>
-        <p:nvSpPr>
-          <p:cNvPr id="3" name="Text Placeholder 2"/>
-          <p:cNvSpPr>
-            <a:spLocks noGrp="1"/>
-          </p:cNvSpPr>
-          <p:nvPr>
-            <p:ph type="body" idx="1"/>
-          </p:nvPr>
-        </p:nvSpPr>
-        <p:spPr/>
-        <p:txBody>
-          <a:bodyPr wrap="square"/>
-          <a:lstStyle/>
-          <a:p>
-            <a:pPr/>
-            <a:r>
-              <a:rPr b="1"/>
-              <a:t>Test ideas live and see the effect on pace and output right away:</a:t>
-            </a:r>
-          </a:p>
-          <a:p>
-            <a:pPr lvl="1"/>
-            <a:r>
-              <a:t>Add help where an operator has idle time, and watch the bottleneck station drop.</a:t>
-            </a:r>
-          </a:p>
-          <a:p>
-            <a:pPr lvl="1"/>
-            <a:r>
-              <a:t>Move a step from one station to another to rebalance the line.</a:t>
-            </a:r>
-          </a:p>
-          <a:p>
-            <a:pPr lvl="1"/>
-            <a:r>
-              <a:t>Run different products on a line (Sola sizes, chair vs swivel) and see labor change.</a:t>
-            </a:r>
-          </a:p>
-          <a:p>
-            <a:pPr lvl="1"/>
-            <a:r>
-              <a:t>Focus on one line at a time, or view all three together.</a:t>
-            </a:r>
-          </a:p>
-          <a:p>
-            <a:pPr/>
-            <a:r>
-              <a:t>It is a thinking tool for line balancing, not just a picture.</a:t>
-            </a:r>
-          </a:p>
-        </p:txBody>
-      </p:sp>
-    </p:spTree>
-  </p:cSld>
-  <p:clrMapOvr>
-    <a:masterClrMapping/>
-  </p:clrMapOvr>
-</p:sld>
-</file>
-
-<file path=ppt/slides/slide5.xml><?xml version="1.0" encoding="utf-8"?>
-<p:sld xmlns:a="http://schemas.openxmlformats.org/drawingml/2006/main" xmlns:p="http://schemas.openxmlformats.org/presentationml/2006/main" xmlns:r="http://schemas.openxmlformats.org/officeDocument/2006/relationships">
-  <p:cSld>
-    <p:spTree>
-      <p:nvGrpSpPr>
-        <p:cNvPr id="1" name=""/>
-        <p:cNvGrpSpPr/>
-        <p:nvPr/>
-      </p:nvGrpSpPr>
-      <p:grpSpPr/>
-      <p:sp>
-        <p:nvSpPr>
-          <p:cNvPr id="2" name="Title 1"/>
-          <p:cNvSpPr>
-            <a:spLocks noGrp="1"/>
-          </p:cNvSpPr>
-          <p:nvPr>
-            <p:ph type="title"/>
-          </p:nvPr>
-        </p:nvSpPr>
-        <p:spPr/>
-        <p:txBody>
-          <a:bodyPr/>
-          <a:lstStyle/>
-          <a:p>
-            <a:r>
-              <a:t>Where the lines stand today</a:t>
-            </a:r>
-          </a:p>
-        </p:txBody>
-      </p:sp>
-      <p:sp>
-        <p:nvSpPr>
-          <p:cNvPr id="3" name="Text Placeholder 2"/>
-          <p:cNvSpPr>
-            <a:spLocks noGrp="1"/>
-          </p:cNvSpPr>
-          <p:nvPr>
-            <p:ph type="body" idx="1"/>
-          </p:nvPr>
-        </p:nvSpPr>
-        <p:spPr/>
-        <p:txBody>
-          <a:bodyPr wrap="square"/>
-          <a:lstStyle/>
-          <a:p>
-            <a:pPr/>
-            <a:r>
-              <a:t>From the current model, at a 7-hour (420 min) working day:</a:t>
-            </a:r>
-          </a:p>
-          <a:p>
-            <a:pPr lvl="1"/>
-            <a:r>
-              <a:t>Meritage 3-Seater:  ~8.6 / day · pace 48.6 min · 272 min labor/unit · bottleneck Seat frame</a:t>
-            </a:r>
-          </a:p>
-          <a:p>
-            <a:pPr lvl="1"/>
-            <a:r>
-              <a:t>Sola Lounge (no arms):  11.0 / day · pace 38.2 min · 168.7 min labor/unit · bottleneck Frame</a:t>
-            </a:r>
-          </a:p>
-          <a:p>
-            <a:pPr lvl="1"/>
-            <a:r>
-              <a:t>Canyon Crew (chair):  14.0 / day · pace 30 min · 99 min labor/unit · bottleneck SWI 10 to 16</a:t>
-            </a:r>
-          </a:p>
-          <a:p>
-            <a:pPr/>
-            <a:r>
-              <a:rPr b="1"/>
-              <a:t>These update the moment we change a time, add help, or rebalance, so we can compare options in the room.</a:t>
-            </a:r>
-          </a:p>
-        </p:txBody>
-      </p:sp>
-    </p:spTree>
-  </p:cSld>
-  <p:clrMapOvr>
-    <a:masterClrMapping/>
-  </p:clrMapOvr>
-</p:sld>
-</file>
-
-<file path=ppt/slides/slide6.xml><?xml version="1.0" encoding="utf-8"?>
 <p:sld xmlns:a="http://schemas.openxmlformats.org/drawingml/2006/main" xmlns:p="http://schemas.openxmlformats.org/presentationml/2006/main" xmlns:r="http://schemas.openxmlformats.org/officeDocument/2006/relationships">
   <p:cSld>
     <p:spTree>
@@ -4409,7 +4216,7 @@
 </p:sld>
 </file>
 
-<file path=ppt/slides/slide7.xml><?xml version="1.0" encoding="utf-8"?>
+<file path=ppt/slides/slide5.xml><?xml version="1.0" encoding="utf-8"?>
 <p:sld xmlns:a="http://schemas.openxmlformats.org/drawingml/2006/main" xmlns:p="http://schemas.openxmlformats.org/presentationml/2006/main" xmlns:r="http://schemas.openxmlformats.org/officeDocument/2006/relationships">
   <p:cSld>
     <p:spTree>
@@ -4435,7 +4242,7 @@
           <a:lstStyle/>
           <a:p>
             <a:r>
-              <a:t>What I would like from you</a:t>
+              <a:t>Where we want to take it</a:t>
             </a:r>
           </a:p>
         </p:txBody>
@@ -4457,105 +4264,26 @@
           <a:p>
             <a:pPr/>
             <a:r>
-              <a:t>Ideas to try: anything you would want to see run on a line.</a:t>
+              <a:rPr b="1"/>
+              <a:t>Turn it into a daily planning tool, split into two roles:</a:t>
+            </a:r>
+          </a:p>
+          <a:p>
+            <a:pPr lvl="1"/>
+            <a:r>
+              <a:t>Admin page: owns the back end and the workflow design, station setup, product step times, line rules.</a:t>
+            </a:r>
+          </a:p>
+          <a:p>
+            <a:pPr lvl="1"/>
+            <a:r>
+              <a:t>Floor manager page: each day, enter the products lined up to build and the people available.</a:t>
             </a:r>
           </a:p>
           <a:p>
             <a:pPr/>
             <a:r>
-              <a:t>Which line should we focus on first for optimization?</a:t>
-            </a:r>
-          </a:p>
-          <a:p>
-            <a:pPr/>
-            <a:r>
-              <a:t>A gut-check on the times and assumptions. A few product times are still estimates, not measured SWIs.</a:t>
-            </a:r>
-          </a:p>
-          <a:p>
-            <a:pPr/>
-            <a:r>
-              <a:t>Where help between stations is realistic vs where it is not, given how the crews actually work.</a:t>
-            </a:r>
-          </a:p>
-        </p:txBody>
-      </p:sp>
-    </p:spTree>
-  </p:cSld>
-  <p:clrMapOvr>
-    <a:masterClrMapping/>
-  </p:clrMapOvr>
-</p:sld>
-</file>
-
-<file path=ppt/slides/slide8.xml><?xml version="1.0" encoding="utf-8"?>
-<p:sld xmlns:a="http://schemas.openxmlformats.org/drawingml/2006/main" xmlns:p="http://schemas.openxmlformats.org/presentationml/2006/main" xmlns:r="http://schemas.openxmlformats.org/officeDocument/2006/relationships">
-  <p:cSld>
-    <p:spTree>
-      <p:nvGrpSpPr>
-        <p:cNvPr id="1" name=""/>
-        <p:cNvGrpSpPr/>
-        <p:nvPr/>
-      </p:nvGrpSpPr>
-      <p:grpSpPr/>
-      <p:sp>
-        <p:nvSpPr>
-          <p:cNvPr id="2" name="Title 1"/>
-          <p:cNvSpPr>
-            <a:spLocks noGrp="1"/>
-          </p:cNvSpPr>
-          <p:nvPr>
-            <p:ph type="title"/>
-          </p:nvPr>
-        </p:nvSpPr>
-        <p:spPr/>
-        <p:txBody>
-          <a:bodyPr/>
-          <a:lstStyle/>
-          <a:p>
-            <a:r>
-              <a:t>Where this is headed</a:t>
-            </a:r>
-          </a:p>
-        </p:txBody>
-      </p:sp>
-      <p:sp>
-        <p:nvSpPr>
-          <p:cNvPr id="3" name="Text Placeholder 2"/>
-          <p:cNvSpPr>
-            <a:spLocks noGrp="1"/>
-          </p:cNvSpPr>
-          <p:nvPr>
-            <p:ph type="body" idx="1"/>
-          </p:nvPr>
-        </p:nvSpPr>
-        <p:spPr/>
-        <p:txBody>
-          <a:bodyPr wrap="square"/>
-          <a:lstStyle/>
-          <a:p>
-            <a:pPr/>
-            <a:r>
-              <a:rPr b="1"/>
-              <a:t>This is a working tool, not a finished hand-off yet.</a:t>
-            </a:r>
-          </a:p>
-          <a:p>
-            <a:pPr/>
-            <a:r>
-              <a:t>Next: move the data to our shared M365 (SharePoint) so a change one person makes updates company-wide.</a:t>
-            </a:r>
-          </a:p>
-          <a:p>
-            <a:pPr/>
-            <a:r>
-              <a:t>Keep grounding product times in real SWIs as we collect them.</a:t>
-            </a:r>
-          </a:p>
-          <a:p>
-            <a:pPr/>
-            <a:r>
-              <a:t>Longer term: pull layouts straight from CAD so the floor always matches the drawing.</a:t>
+              <a:t>The tool then shows the best way to run the lines that day, staffing, help, and balance, to optimize output.</a:t>
             </a:r>
           </a:p>
         </p:txBody>

</xml_diff>